<commit_message>
docs(stage1): write the video script per slide with no assigned speakers
Co-Authored-By: Claude Opus 5.5 (1M context) <noreply@anthropic.com>
Claude-Session: https://claude.ai/code/session_01E6T3RQuXLZL6qBycTZKaNm
</commit_message>
<xml_diff>
--- a/submission/stage1/ELEC5620_Stage1_Slides.pptx
+++ b/submission/stage1/ELEC5620_Stage1_Slides.pptx
@@ -525,7 +525,7 @@
           <a:lstStyle/>
           <a:p>
             <a:r>
-              <a:t>Speaker A. Hi, I'm Ziqi He, member A. We are Group 14 from the Monday 10 to 12 class, and this is AI Trip Planner, a one-person AI travel agency. Each of us will present our own part.</a:t>
+              <a:t>Hi, we are Group 14 from the Monday 10 to 12 class, and this is AI Trip Planner, a one-person AI travel agency.</a:t>
             </a:r>
           </a:p>
         </p:txBody>
@@ -595,7 +595,7 @@
           <a:lstStyle/>
           <a:p>
             <a:r>
-              <a:t>Speaker C. I'm Yi Qiao, member C. I own accommodation and budget. My ad hoc requirement: the hotel must fit the money left after flights, a budget overrun should swap to a cheaper hotel that still meets my rules, and an impossible budget should name the minimum. That gave my two use cases.</a:t>
+              <a:t>Member C owns accommodation and budget. The ad hoc requirement: the hotel must fit the money left after flights, a budget overrun should swap to a cheaper hotel that still meets the traveller's rules, and an impossible budget should name the minimum. That gave two use cases.</a:t>
             </a:r>
           </a:p>
         </p:txBody>
@@ -665,7 +665,7 @@
           <a:lstStyle/>
           <a:p>
             <a:r>
-              <a:t>Speaker C. The object diagram snapshots the planning board for a Tokyo trip that is 640 dollars over budget. The hotel prices are real fixture values; transport and dining are illustrative. Accommodation is asked to save 379 dollars, so it moves to the saver hotel.</a:t>
+              <a:t>The object diagram snapshots the planning board for a Tokyo trip that is 640 dollars over budget. The hotel prices are real fixture values; transport and dining are illustrative. Accommodation is asked to save 379 dollars, so it moves to the saver hotel.</a:t>
             </a:r>
           </a:p>
         </p:txBody>
@@ -735,7 +735,7 @@
           <a:lstStyle/>
           <a:p>
             <a:r>
-              <a:t>Speaker C. The collaboration shows roles, not classes: my budget code plays the judge that turns proposals into targeted revisions. The structured class shows the workflow's parts and its injected ports.</a:t>
+              <a:t>The collaboration shows roles, not classes: the budget code plays the judge that turns proposals into targeted revisions. The structured class shows the workflow's parts and its injected ports.</a:t>
             </a:r>
           </a:p>
         </p:txBody>
@@ -805,7 +805,7 @@
           <a:lstStyle/>
           <a:p>
             <a:r>
-              <a:t>Speaker C. In my activity diagram the LLM appears once, choosing one candidate id. Around it everything is deterministic: invalid output falls back to a rule, a booked stay skips the search, and prices are in cents.</a:t>
+              <a:t>In this activity diagram the LLM appears once, choosing one candidate id. Around it everything is deterministic: invalid output falls back to a rule, a booked stay skips the search, and prices are in cents.</a:t>
             </a:r>
           </a:p>
         </p:txBody>
@@ -875,7 +875,7 @@
           <a:lstStyle/>
           <a:p>
             <a:r>
-              <a:t>Speaker C. The sequence diagram shows an overrun: my detectConflicts sends a revision only to the agents that can cut, and round two is kept only because the plan score improved.</a:t>
+              <a:t>The sequence diagram shows an overrun: detectConflicts sends a revision only to the agents that can cut, and round two is kept only because the plan score improved.</a:t>
             </a:r>
           </a:p>
         </p:txBody>
@@ -945,7 +945,7 @@
           <a:lstStyle/>
           <a:p>
             <a:r>
-              <a:t>Speaker C. The state machine follows the accommodation section through one turn, and maps its internal states onto the three statuses the traveller sees. Over to D.</a:t>
+              <a:t>The state machine follows the accommodation section through one turn, and maps its internal states onto the three statuses the traveller sees.</a:t>
             </a:r>
           </a:p>
         </p:txBody>
@@ -1015,7 +1015,7 @@
           <a:lstStyle/>
           <a:p>
             <a:r>
-              <a:t>Speaker D. I'm Jiahang Bian, member D. Our class model has six diagrams drawn from the code. The spine runs from the workspace, through the coordinator and workflow, to specialists that reach tools and memory only through injected interfaces.</a:t>
+              <a:t>Our class model has six diagrams drawn from the code. The spine runs from the workspace, through the coordinator and workflow, to specialists that reach tools and memory only through injected interfaces.</a:t>
             </a:r>
           </a:p>
         </p:txBody>
@@ -1085,7 +1085,7 @@
           <a:lstStyle/>
           <a:p>
             <a:r>
-              <a:t>Speaker D. Every agent realises one Specialist interface, so the graph loops over them without knowing their models. The registry aggregates agents, while a plan is composed of its sections.</a:t>
+              <a:t>Every agent realises one Specialist interface, so the graph loops over them without knowing their models. The registry aggregates agents, while a plan is composed of its sections.</a:t>
             </a:r>
           </a:p>
         </p:txBody>
@@ -1155,7 +1155,7 @@
           <a:lstStyle/>
           <a:p>
             <a:r>
-              <a:t>Speaker D. We discarded a model-driven loop and free agent-to-agent chat, because limits and costs must be testable. We dropped approval checkpoints, since confirming applied nothing, and chose DeepSeek because it was about three times faster.</a:t>
+              <a:t>We discarded a model-driven loop and free agent-to-agent chat, because limits and costs must be testable. We dropped approval checkpoints, since confirming applied nothing, and chose DeepSeek because it was about three times faster.</a:t>
             </a:r>
           </a:p>
         </p:txBody>
@@ -1225,7 +1225,7 @@
           <a:lstStyle/>
           <a:p>
             <a:r>
-              <a:t>Speaker D. [About 25 seconds. Name your ad hoc requirement and use case, then point to where the LLM sits in each diagram and which code checks it. Replace the three placeholders with your diagrams.]</a:t>
+              <a:t>[About 25 seconds. Name member D's ad hoc requirement and use case, then point to where the LLM sits in each diagram and which code checks it. Replace the three placeholders with the diagrams.]</a:t>
             </a:r>
           </a:p>
         </p:txBody>
@@ -1295,7 +1295,7 @@
           <a:lstStyle/>
           <a:p>
             <a:r>
-              <a:t>Speaker A. Planning a trip means juggling many sites, and every choice constrains the others. A chatbot can write an itinerary, but it invents prices and never checks that the parts fit. So we built an agency where specialist agents plan together on real data, and code checks their work.</a:t>
+              <a:t>Planning a trip means juggling many sites, and every choice constrains the others. A chatbot can write an itinerary, but it invents prices and never checks that the parts fit. So we built an agency where specialist agents plan together on real data, and code checks their work.</a:t>
             </a:r>
           </a:p>
         </p:txBody>
@@ -1365,7 +1365,7 @@
           <a:lstStyle/>
           <a:p>
             <a:r>
-              <a:t>Speaker E. I'm Weihao Wang, member E. Six packages, each with an owner, all depend inward on the shared contracts, which depend on nothing. New specialists, providers or stores plug in behind existing interfaces.</a:t>
+              <a:t>Six packages, each with an owner, all depend inward on the shared contracts, which depend on nothing. New specialists, providers or stores plug in behind existing interfaces.</a:t>
             </a:r>
           </a:p>
         </p:txBody>
@@ -1435,7 +1435,7 @@
           <a:lstStyle/>
           <a:p>
             <a:r>
-              <a:t>Speaker E. It deploys as one serverless Next.js app. Memory, account sync and sign-in are optional, and without keys the same build runs fully on mock data.</a:t>
+              <a:t>It deploys as one serverless Next.js app. Memory, account sync and sign-in are optional, and without keys the same build runs fully on mock data.</a:t>
             </a:r>
           </a:p>
         </p:txBody>
@@ -1505,7 +1505,7 @@
           <a:lstStyle/>
           <a:p>
             <a:r>
-              <a:t>Speaker E. A change must trace to a requirement; a change to shared contracts needs a written decision. A pull request is accepted when CI passes, an end-to-end artifact exists, use case postconditions hold and the models are updated.</a:t>
+              <a:t>A change must trace to a requirement; a change to shared contracts needs a written decision. A pull request is accepted when CI passes, an end-to-end artifact exists, use case postconditions hold and the models are updated.</a:t>
             </a:r>
           </a:p>
         </p:txBody>
@@ -1575,7 +1575,7 @@
           <a:lstStyle/>
           <a:p>
             <a:r>
-              <a:t>Speaker E. [About 25 seconds. Name your ad hoc requirement and use case, then point to where the LLM sits in each diagram and which code checks it. Replace the three placeholders with your diagrams.]</a:t>
+              <a:t>[About 25 seconds. Name member E's ad hoc requirement and use case, then point to where the LLM sits in each diagram and which code checks it. Replace the three placeholders with the diagrams.]</a:t>
             </a:r>
           </a:p>
         </p:txBody>
@@ -1645,7 +1645,7 @@
           <a:lstStyle/>
           <a:p>
             <a:r>
-              <a:t>Speaker E. In short: models choose, code decides, and the traveller stays in control. Thank you for watching.</a:t>
+              <a:t>In short: models choose, code decides, and the traveller stays in control. Thank you for watching.</a:t>
             </a:r>
           </a:p>
         </p:txBody>
@@ -1715,7 +1715,7 @@
           <a:lstStyle/>
           <a:p>
             <a:r>
-              <a:t>Speaker A. There are two humans: the traveller, our customer, and the founder who runs the agency and tests the agents in our Agent Lab. Then seven AI roles: a coordinator that talks to the traveller, a supervisor that assigns work, and five specialists, each with its own prompt and tools.</a:t>
+              <a:t>There are two humans: the traveller, our customer, and the founder who runs the agency and tests the agents in our Agent Lab. Then seven AI roles: a coordinator that talks to the traveller, a supervisor that assigns work, and five specialists, each with its own prompt and tools.</a:t>
             </a:r>
           </a:p>
         </p:txBody>
@@ -1785,7 +1785,7 @@
           <a:lstStyle/>
           <a:p>
             <a:r>
-              <a:t>Speaker A. Our key design choice: the LangGraph workflow drives the agents, not the other way round. Specialists plan in stages on a shared board, code detects budget, time and route conflicts, and only the agents involved revise, for at most three rounds. If a model fails, a validated fallback keeps planning working.</a:t>
+              <a:t>Our key design choice: the LangGraph workflow drives the agents, not the other way round. Specialists plan in stages on a shared board, code detects budget, time and route conflicts, and only the agents involved revise, for at most three rounds. If a model fails, a validated fallback keeps planning working.</a:t>
             </a:r>
           </a:p>
         </p:txBody>
@@ -1855,7 +1855,7 @@
           <a:lstStyle/>
           <a:p>
             <a:r>
-              <a:t>Speaker A. [About 25 seconds. Name your ad hoc requirement and use case, then point to where the LLM sits in each diagram and which code checks it. Replace the three placeholders with your diagrams.]</a:t>
+              <a:t>[About 25 seconds. Name member A's ad hoc requirement and use case, then point to where the LLM sits in each diagram and which code checks it. Replace the three placeholders with the diagrams.]</a:t>
             </a:r>
           </a:p>
         </p:txBody>
@@ -1925,7 +1925,7 @@
           <a:lstStyle/>
           <a:p>
             <a:r>
-              <a:t>Speaker B. I'm Tingsong Jin, member B. We classified requirements into the agreed scope, mandatory capabilities and optional features. Each member owns two core features and one optional one, shown here. Every member also wrote an ad hoc requirement and broke it into functional, non-functional and constraint requirements.</a:t>
+              <a:t>We classified requirements into the agreed scope, mandatory capabilities and optional features. Each member owns two core features and one optional one, shown here. Every member also wrote an ad hoc requirement and broke it into functional, non-functional and constraint requirements.</a:t>
             </a:r>
           </a:p>
         </p:txBody>
@@ -1995,7 +1995,7 @@
           <a:lstStyle/>
           <a:p>
             <a:r>
-              <a:t>Speaker B. The feature diagram groups the system into seven areas, with mandatory, optional and alternative features, such as shared or individual rooms. We added cross-tree constraints and attached non-functional requirements, like money in integer cents.</a:t>
+              <a:t>The feature diagram groups the system into seven areas, with mandatory, optional and alternative features, such as shared or individual rooms. We added cross-tree constraints and attached non-functional requirements, like money in integer cents.</a:t>
             </a:r>
           </a:p>
         </p:txBody>
@@ -2065,7 +2065,7 @@
           <a:lstStyle/>
           <a:p>
             <a:r>
-              <a:t>Speaker B. The use case diagram has one traveller and three external systems. Each member wrote at least one full specification, and our behaviour diagrams come from those.</a:t>
+              <a:t>The use case diagram has one traveller and three external systems. Each member wrote at least one full specification, and our behaviour diagrams come from those.</a:t>
             </a:r>
           </a:p>
         </p:txBody>
@@ -2135,7 +2135,7 @@
           <a:lstStyle/>
           <a:p>
             <a:r>
-              <a:t>Speaker B. [About 25 seconds. Name your ad hoc requirement and use case, then point to where the LLM sits in each diagram and which code checks it. Replace the three placeholders with your diagrams.]</a:t>
+              <a:t>[About 25 seconds. Name member B's ad hoc requirement and use case, then point to where the LLM sits in each diagram and which code checks it. Replace the three placeholders with the diagrams.]</a:t>
             </a:r>
           </a:p>
         </p:txBody>

</xml_diff>